<commit_message>
neurobyte-web: ~590 scorers, two networks; dev labels used to report and compare (not 'test only')
</commit_message>
<xml_diff>
--- a/neurobyte-web/presentation/NeuroBytes_overview_v2.pptx
+++ b/neurobyte-web/presentation/NeuroBytes_overview_v2.pptx
@@ -7755,7 +7755,7 @@
                 </a:solidFill>
                 <a:latin typeface="Inter"/>
               </a:rPr>
-              <a:t>rank fusion of ~650 scorers</a:t>
+              <a:t>rank fusion of ~590 scorers</a:t>
             </a:r>
           </a:p>
         </p:txBody>
@@ -8007,7 +8007,7 @@
                 </a:solidFill>
                 <a:latin typeface="Inter"/>
               </a:rPr>
-              <a:t>~650 brain-to-video scorers</a:t>
+              <a:t>~590 brain-to-video scorers</a:t>
             </a:r>
           </a:p>
         </p:txBody>
@@ -8049,7 +8049,7 @@
                 </a:solidFill>
                 <a:latin typeface="Inter"/>
               </a:rPr>
-              <a:t>Ridge decoders over latency windows × deep video features, plus a contrastive net across people.</a:t>
+              <a:t>Ridge decoders over latency windows × deep video features, plus two contrastive nets across people.</a:t>
             </a:r>
           </a:p>
         </p:txBody>

</xml_diff>